<commit_message>
docs(projects): atualiza apresentação B_M e ignora backups locais
Atualiza o PPTX de São Paulo e adiciona .gitignore em projects/B_M para não versionar ficheiros *.bak.
</commit_message>
<xml_diff>
--- a/projects/B_M/Apresentação Empresas Sro Paulo.pptx
+++ b/projects/B_M/Apresentação Empresas Sro Paulo.pptx
@@ -6749,7 +6749,7 @@
         </p:nvSpPr>
         <p:spPr>
           <a:xfrm>
-            <a:off x="7080490" y="2205973"/>
+            <a:off x="7059168" y="2205973"/>
             <a:ext cx="4448576" cy="276999"/>
           </a:xfrm>
           <a:prstGeom prst="rect">
@@ -6765,58 +6765,22 @@
           <a:p>
             <a:pPr algn="l"/>
             <a:r>
-              <a:rPr lang="pt-BR" sz="1200" b="0" i="0" dirty="0">
+              <a:rPr sz="1200" b="1">
                 <a:solidFill>
                   <a:srgbClr val="C9A84C"/>
                 </a:solidFill>
                 <a:latin typeface="Open Sans"/>
               </a:rPr>
-              <a:t> </a:t>
-            </a:r>
-            <a:r>
-              <a:rPr sz="1200" b="0" i="0" dirty="0" err="1">
+              <a:t>✓  </a:t>
+            </a:r>
+            <a:r>
+              <a:rPr sz="1200" b="0">
                 <a:solidFill>
                   <a:srgbClr val="C9A84C"/>
                 </a:solidFill>
                 <a:latin typeface="Open Sans"/>
               </a:rPr>
-              <a:t>Mesmo</a:t>
-            </a:r>
-            <a:r>
-              <a:rPr sz="1200" b="0" i="0" dirty="0">
-                <a:solidFill>
-                  <a:srgbClr val="C9A84C"/>
-                </a:solidFill>
-                <a:latin typeface="Open Sans"/>
-              </a:rPr>
-              <a:t> </a:t>
-            </a:r>
-            <a:r>
-              <a:rPr sz="1200" b="0" i="0" dirty="0" err="1">
-                <a:solidFill>
-                  <a:srgbClr val="C9A84C"/>
-                </a:solidFill>
-                <a:latin typeface="Open Sans"/>
-              </a:rPr>
-              <a:t>dia</a:t>
-            </a:r>
-            <a:r>
-              <a:rPr sz="1200" b="0" i="0" dirty="0">
-                <a:solidFill>
-                  <a:srgbClr val="C9A84C"/>
-                </a:solidFill>
-                <a:latin typeface="Open Sans"/>
-              </a:rPr>
-              <a:t> / </a:t>
-            </a:r>
-            <a:r>
-              <a:rPr sz="1200" b="0" i="0" dirty="0" err="1">
-                <a:solidFill>
-                  <a:srgbClr val="C9A84C"/>
-                </a:solidFill>
-                <a:latin typeface="Open Sans"/>
-              </a:rPr>
-              <a:t>Agendado</a:t>
+              <a:t>Mesmo dia / Agendado</a:t>
             </a:r>
             <a:endParaRPr sz="1200" b="0" i="0" dirty="0">
               <a:solidFill>
@@ -7037,7 +7001,7 @@
         </p:nvSpPr>
         <p:spPr>
           <a:xfrm>
-            <a:off x="7027156" y="2913109"/>
+            <a:off x="7059168" y="2913109"/>
             <a:ext cx="4448576" cy="276999"/>
           </a:xfrm>
           <a:prstGeom prst="rect">
@@ -7053,49 +7017,22 @@
           <a:p>
             <a:pPr algn="l"/>
             <a:r>
-              <a:rPr lang="pt-BR" sz="1200" b="0" i="0" dirty="0">
+              <a:rPr sz="1200" b="1">
                 <a:solidFill>
                   <a:srgbClr val="C9A84C"/>
                 </a:solidFill>
                 <a:latin typeface="Open Sans"/>
               </a:rPr>
-              <a:t> </a:t>
-            </a:r>
-            <a:r>
-              <a:rPr sz="1200" b="0" i="0" dirty="0">
+              <a:t>✓  </a:t>
+            </a:r>
+            <a:r>
+              <a:rPr sz="1200" b="0">
                 <a:solidFill>
                   <a:srgbClr val="C9A84C"/>
                 </a:solidFill>
                 <a:latin typeface="Open Sans"/>
               </a:rPr>
-              <a:t>Leva-e-</a:t>
-            </a:r>
-            <a:r>
-              <a:rPr sz="1200" b="0" i="0" dirty="0" err="1">
-                <a:solidFill>
-                  <a:srgbClr val="C9A84C"/>
-                </a:solidFill>
-                <a:latin typeface="Open Sans"/>
-              </a:rPr>
-              <a:t>traz</a:t>
-            </a:r>
-            <a:r>
-              <a:rPr sz="1200" b="0" i="0" dirty="0">
-                <a:solidFill>
-                  <a:srgbClr val="C9A84C"/>
-                </a:solidFill>
-                <a:latin typeface="Open Sans"/>
-              </a:rPr>
-              <a:t> </a:t>
-            </a:r>
-            <a:r>
-              <a:rPr sz="1200" b="0" i="0" dirty="0" err="1">
-                <a:solidFill>
-                  <a:srgbClr val="C9A84C"/>
-                </a:solidFill>
-                <a:latin typeface="Open Sans"/>
-              </a:rPr>
-              <a:t>incluso</a:t>
+              <a:t>Leva-e-traz incluso</a:t>
             </a:r>
             <a:endParaRPr sz="1200" b="0" i="0" dirty="0">
               <a:solidFill>
@@ -7316,7 +7253,7 @@
         </p:nvSpPr>
         <p:spPr>
           <a:xfrm>
-            <a:off x="7080490" y="3620245"/>
+            <a:off x="7059168" y="3620245"/>
             <a:ext cx="4448576" cy="600470"/>
           </a:xfrm>
           <a:prstGeom prst="rect">
@@ -7332,7 +7269,16 @@
           <a:p>
             <a:pPr algn="l"/>
             <a:r>
-              <a:rPr sz="1200" b="0" i="0">
+              <a:rPr sz="1200" b="1">
+                <a:solidFill>
+                  <a:srgbClr val="C9A84C"/>
+                </a:solidFill>
+                <a:latin typeface="Open Sans"/>
+              </a:rPr>
+              <a:t>✓  </a:t>
+            </a:r>
+            <a:r>
+              <a:rPr sz="1200" b="0">
                 <a:solidFill>
                   <a:srgbClr val="C9A84C"/>
                 </a:solidFill>
@@ -7562,7 +7508,7 @@
         </p:nvSpPr>
         <p:spPr>
           <a:xfrm>
-            <a:off x="7080490" y="4327381"/>
+            <a:off x="7059168" y="4327381"/>
             <a:ext cx="4448576" cy="600470"/>
           </a:xfrm>
           <a:prstGeom prst="rect">
@@ -7578,7 +7524,16 @@
           <a:p>
             <a:pPr algn="l"/>
             <a:r>
-              <a:rPr sz="1200" b="0" i="0">
+              <a:rPr sz="1200" b="1">
+                <a:solidFill>
+                  <a:srgbClr val="C9A84C"/>
+                </a:solidFill>
+                <a:latin typeface="Open Sans"/>
+              </a:rPr>
+              <a:t>✓  </a:t>
+            </a:r>
+            <a:r>
+              <a:rPr sz="1200" b="0">
                 <a:solidFill>
                   <a:srgbClr val="C9A84C"/>
                 </a:solidFill>
@@ -7799,7 +7754,7 @@
         </p:nvSpPr>
         <p:spPr>
           <a:xfrm>
-            <a:off x="7080490" y="5034517"/>
+            <a:off x="7059168" y="5034517"/>
             <a:ext cx="4448576" cy="276999"/>
           </a:xfrm>
           <a:prstGeom prst="rect">
@@ -7815,31 +7770,22 @@
           <a:p>
             <a:pPr algn="l"/>
             <a:r>
-              <a:rPr sz="1200" b="0" i="0" dirty="0" err="1">
+              <a:rPr sz="1200" b="1">
                 <a:solidFill>
                   <a:srgbClr val="C9A84C"/>
                 </a:solidFill>
                 <a:latin typeface="Open Sans"/>
               </a:rPr>
-              <a:t>Homologadas</a:t>
-            </a:r>
-            <a:r>
-              <a:rPr sz="1200" b="0" i="0" dirty="0">
+              <a:t>✓  </a:t>
+            </a:r>
+            <a:r>
+              <a:rPr sz="1200" b="0">
                 <a:solidFill>
                   <a:srgbClr val="C9A84C"/>
                 </a:solidFill>
                 <a:latin typeface="Open Sans"/>
               </a:rPr>
-              <a:t> e </a:t>
-            </a:r>
-            <a:r>
-              <a:rPr lang="pt-BR" sz="1200" dirty="0">
-                <a:solidFill>
-                  <a:srgbClr val="C9A84C"/>
-                </a:solidFill>
-                <a:latin typeface="Open Sans"/>
-              </a:rPr>
-              <a:t>prime</a:t>
+              <a:t>Homologadas e prime</a:t>
             </a:r>
             <a:endParaRPr sz="1200" b="0" i="0" dirty="0">
               <a:solidFill>
@@ -8060,7 +8006,7 @@
         </p:nvSpPr>
         <p:spPr>
           <a:xfrm>
-            <a:off x="7080490" y="5741653"/>
+            <a:off x="7059168" y="5741653"/>
             <a:ext cx="4448576" cy="600470"/>
           </a:xfrm>
           <a:prstGeom prst="rect">
@@ -8076,40 +8022,22 @@
           <a:p>
             <a:pPr algn="l"/>
             <a:r>
-              <a:rPr sz="1200" b="0" i="0" dirty="0">
+              <a:rPr sz="1200" b="1">
                 <a:solidFill>
                   <a:srgbClr val="C9A84C"/>
                 </a:solidFill>
                 <a:latin typeface="Open Sans"/>
               </a:rPr>
-              <a:t>90 </a:t>
-            </a:r>
-            <a:r>
-              <a:rPr sz="1200" b="0" i="0" dirty="0" err="1">
+              <a:t>✓  </a:t>
+            </a:r>
+            <a:r>
+              <a:rPr sz="1200" b="0">
                 <a:solidFill>
                   <a:srgbClr val="C9A84C"/>
                 </a:solidFill>
                 <a:latin typeface="Open Sans"/>
               </a:rPr>
-              <a:t>dias</a:t>
-            </a:r>
-            <a:r>
-              <a:rPr sz="1200" b="0" i="0" dirty="0">
-                <a:solidFill>
-                  <a:srgbClr val="C9A84C"/>
-                </a:solidFill>
-                <a:latin typeface="Open Sans"/>
-              </a:rPr>
-              <a:t> </a:t>
-            </a:r>
-            <a:r>
-              <a:rPr sz="1200" b="0" i="0" dirty="0" err="1">
-                <a:solidFill>
-                  <a:srgbClr val="C9A84C"/>
-                </a:solidFill>
-                <a:latin typeface="Open Sans"/>
-              </a:rPr>
-              <a:t>formais</a:t>
+              <a:t>90 dias formais</a:t>
             </a:r>
             <a:endParaRPr sz="1200" b="0" i="0" dirty="0">
               <a:solidFill>
@@ -8345,7 +8273,7 @@
         </p:nvSpPr>
         <p:spPr>
           <a:xfrm>
-            <a:off x="7080490" y="6448789"/>
+            <a:off x="7059168" y="6448789"/>
             <a:ext cx="4448576" cy="600470"/>
           </a:xfrm>
           <a:prstGeom prst="rect">
@@ -8361,31 +8289,22 @@
           <a:p>
             <a:pPr algn="l"/>
             <a:r>
-              <a:rPr sz="1200" b="0" i="0" dirty="0" err="1">
+              <a:rPr sz="1200" b="1">
                 <a:solidFill>
                   <a:srgbClr val="C9A84C"/>
                 </a:solidFill>
                 <a:latin typeface="Open Sans"/>
               </a:rPr>
-              <a:t>Infraestrutura</a:t>
-            </a:r>
-            <a:r>
-              <a:rPr sz="1200" b="0" i="0" dirty="0">
+              <a:t>✓  </a:t>
+            </a:r>
+            <a:r>
+              <a:rPr sz="1200" b="0">
                 <a:solidFill>
                   <a:srgbClr val="C9A84C"/>
                 </a:solidFill>
                 <a:latin typeface="Open Sans"/>
               </a:rPr>
-              <a:t> </a:t>
-            </a:r>
-            <a:r>
-              <a:rPr sz="1200" b="0" i="0" dirty="0" err="1">
-                <a:solidFill>
-                  <a:srgbClr val="C9A84C"/>
-                </a:solidFill>
-                <a:latin typeface="Open Sans"/>
-              </a:rPr>
-              <a:t>certificada</a:t>
+              <a:t>Infraestrutura certificada</a:t>
             </a:r>
             <a:endParaRPr sz="1200" b="0" i="0" dirty="0">
               <a:solidFill>

</xml_diff>

<commit_message>
docs(projects): atualiza apresentação B_M São Paulo
Atualiza o ficheiro PPTX da apresentação empresas Sro Paulo.
</commit_message>
<xml_diff>
--- a/projects/B_M/Apresentação Empresas Sro Paulo.pptx
+++ b/projects/B_M/Apresentação Empresas Sro Paulo.pptx
@@ -6765,7 +6765,7 @@
           <a:p>
             <a:pPr algn="l"/>
             <a:r>
-              <a:rPr sz="1200" b="1">
+              <a:rPr sz="1800" b="1">
                 <a:solidFill>
                   <a:srgbClr val="C9A84C"/>
                 </a:solidFill>
@@ -7017,7 +7017,7 @@
           <a:p>
             <a:pPr algn="l"/>
             <a:r>
-              <a:rPr sz="1200" b="1">
+              <a:rPr sz="1800" b="1">
                 <a:solidFill>
                   <a:srgbClr val="C9A84C"/>
                 </a:solidFill>
@@ -7269,7 +7269,7 @@
           <a:p>
             <a:pPr algn="l"/>
             <a:r>
-              <a:rPr sz="1200" b="1">
+              <a:rPr sz="1800" b="1">
                 <a:solidFill>
                   <a:srgbClr val="C9A84C"/>
                 </a:solidFill>
@@ -7524,7 +7524,7 @@
           <a:p>
             <a:pPr algn="l"/>
             <a:r>
-              <a:rPr sz="1200" b="1">
+              <a:rPr sz="1800" b="1">
                 <a:solidFill>
                   <a:srgbClr val="C9A84C"/>
                 </a:solidFill>
@@ -7770,7 +7770,7 @@
           <a:p>
             <a:pPr algn="l"/>
             <a:r>
-              <a:rPr sz="1200" b="1">
+              <a:rPr sz="1800" b="1">
                 <a:solidFill>
                   <a:srgbClr val="C9A84C"/>
                 </a:solidFill>
@@ -8022,7 +8022,7 @@
           <a:p>
             <a:pPr algn="l"/>
             <a:r>
-              <a:rPr sz="1200" b="1">
+              <a:rPr sz="1800" b="1">
                 <a:solidFill>
                   <a:srgbClr val="C9A84C"/>
                 </a:solidFill>
@@ -8289,7 +8289,7 @@
           <a:p>
             <a:pPr algn="l"/>
             <a:r>
-              <a:rPr sz="1200" b="1">
+              <a:rPr sz="1800" b="1">
                 <a:solidFill>
                   <a:srgbClr val="C9A84C"/>
                 </a:solidFill>

</xml_diff>